<commit_message>
Sjöskolan vecka 41–45: kanonisk notation för effekt-, resistans- och felstorheter
Co-Authored-By: Claude Opus 5.5 <noreply@anthropic.com>
Claude-Session: https://claude.ai/code/session_011V9KjBb53XrDm23Dw58SH3
</commit_message>
<xml_diff>
--- a/sjoskolan/vecka-41/aktuell/v41_02_Y_och_trefaseffekt_elev.pptx
+++ b/sjoskolan/vecka-41/aktuell/v41_02_Y_och_trefaseffekt_elev.pptx
@@ -9594,7 +9594,51 @@
                 <a:ea typeface="Calibri"/>
                 <a:cs typeface="Calibri"/>
               </a:rPr>
-              <a:t>Pᵢₙ = Paxel/η</a:t>
+              <a:t>P</a:t>
+            </a:r>
+            <a:r>
+              <a:rPr sz="2925" b="1" baseline="-25000">
+                <a:solidFill>
+                  <a:srgbClr val="064F91"/>
+                </a:solidFill>
+                <a:latin typeface="Calibri"/>
+                <a:ea typeface="Calibri"/>
+                <a:cs typeface="Calibri"/>
+              </a:rPr>
+              <a:t>in</a:t>
+            </a:r>
+            <a:r>
+              <a:rPr sz="2925" b="1">
+                <a:solidFill>
+                  <a:srgbClr val="064F91"/>
+                </a:solidFill>
+                <a:latin typeface="Calibri"/>
+                <a:ea typeface="Calibri"/>
+                <a:cs typeface="Calibri"/>
+              </a:rPr>
+              <a:t> = P</a:t>
+            </a:r>
+            <a:r>
+              <a:rPr sz="2925" b="1" baseline="-25000">
+                <a:solidFill>
+                  <a:srgbClr val="064F91"/>
+                </a:solidFill>
+                <a:latin typeface="Calibri"/>
+                <a:ea typeface="Calibri"/>
+                <a:cs typeface="Calibri"/>
+              </a:rPr>
+              <a:t>axel</a:t>
+            </a:r>
+            <a:r>
+              <a:rPr sz="2925" b="1">
+                <a:solidFill>
+                  <a:srgbClr val="064F91"/>
+                </a:solidFill>
+                <a:latin typeface="Calibri"/>
+                <a:ea typeface="Calibri"/>
+                <a:cs typeface="Calibri"/>
+              </a:rPr>
+              <a:t>/η</a:t>
             </a:r>
           </a:p>
         </p:txBody>
@@ -9652,7 +9696,51 @@
                 <a:ea typeface="Calibri"/>
                 <a:cs typeface="Calibri"/>
               </a:rPr>
-              <a:t>Paxel = 11 kW, η = 0,90 ger Pᵢₙ ≈ 12,2 kW.</a:t>
+              <a:t>P</a:t>
+            </a:r>
+            <a:r>
+              <a:rPr sz="2100" b="0" baseline="-25000">
+                <a:solidFill>
+                  <a:srgbClr val="111111"/>
+                </a:solidFill>
+                <a:latin typeface="Calibri"/>
+                <a:ea typeface="Calibri"/>
+                <a:cs typeface="Calibri"/>
+              </a:rPr>
+              <a:t>axel</a:t>
+            </a:r>
+            <a:r>
+              <a:rPr sz="2100" b="0">
+                <a:solidFill>
+                  <a:srgbClr val="111111"/>
+                </a:solidFill>
+                <a:latin typeface="Calibri"/>
+                <a:ea typeface="Calibri"/>
+                <a:cs typeface="Calibri"/>
+              </a:rPr>
+              <a:t> = 11 kW, η = 0,90 ger P</a:t>
+            </a:r>
+            <a:r>
+              <a:rPr sz="2100" b="0" baseline="-25000">
+                <a:solidFill>
+                  <a:srgbClr val="111111"/>
+                </a:solidFill>
+                <a:latin typeface="Calibri"/>
+                <a:ea typeface="Calibri"/>
+                <a:cs typeface="Calibri"/>
+              </a:rPr>
+              <a:t>in</a:t>
+            </a:r>
+            <a:r>
+              <a:rPr sz="2100" b="0">
+                <a:solidFill>
+                  <a:srgbClr val="111111"/>
+                </a:solidFill>
+                <a:latin typeface="Calibri"/>
+                <a:ea typeface="Calibri"/>
+                <a:cs typeface="Calibri"/>
+              </a:rPr>
+              <a:t> ≈ 12,2 kW.</a:t>
             </a:r>
           </a:p>
           <a:p xmlns:a="http://schemas.openxmlformats.org/drawingml/2006/main">
@@ -9770,7 +9858,7 @@
           <p:nvPr/>
         </p:nvPicPr>
         <p:blipFill>
-          <a:blip r:embed="rId3"/>
+          <a:blip r:embed="rId4"/>
           <a:stretch>
             <a:fillRect/>
           </a:stretch>
@@ -10024,7 +10112,51 @@
                 <a:ea typeface="Calibri"/>
                 <a:cs typeface="Calibri"/>
               </a:rPr>
-              <a:t>U₁,gren/U₂,gren = N₁/N₂</a:t>
+              <a:t>U</a:t>
+            </a:r>
+            <a:r>
+              <a:rPr sz="2925" b="1" baseline="-25000">
+                <a:solidFill>
+                  <a:srgbClr val="064F91"/>
+                </a:solidFill>
+                <a:latin typeface="Calibri"/>
+                <a:ea typeface="Calibri"/>
+                <a:cs typeface="Calibri"/>
+              </a:rPr>
+              <a:t>1,gren</a:t>
+            </a:r>
+            <a:r>
+              <a:rPr sz="2925" b="1">
+                <a:solidFill>
+                  <a:srgbClr val="064F91"/>
+                </a:solidFill>
+                <a:latin typeface="Calibri"/>
+                <a:ea typeface="Calibri"/>
+                <a:cs typeface="Calibri"/>
+              </a:rPr>
+              <a:t>/U</a:t>
+            </a:r>
+            <a:r>
+              <a:rPr sz="2925" b="1" baseline="-25000">
+                <a:solidFill>
+                  <a:srgbClr val="064F91"/>
+                </a:solidFill>
+                <a:latin typeface="Calibri"/>
+                <a:ea typeface="Calibri"/>
+                <a:cs typeface="Calibri"/>
+              </a:rPr>
+              <a:t>2,gren</a:t>
+            </a:r>
+            <a:r>
+              <a:rPr sz="2925" b="1">
+                <a:solidFill>
+                  <a:srgbClr val="064F91"/>
+                </a:solidFill>
+                <a:latin typeface="Calibri"/>
+                <a:ea typeface="Calibri"/>
+                <a:cs typeface="Calibri"/>
+              </a:rPr>
+              <a:t> = N₁/N₂</a:t>
             </a:r>
           </a:p>
         </p:txBody>
@@ -10368,7 +10500,29 @@
                 <a:ea typeface="Calibri"/>
                 <a:cs typeface="Calibri"/>
               </a:rPr>
-              <a:t>Motor: Paxel = 2,4 kW, η = 0,80, PF = 0,75 och U</a:t>
+              <a:t>Motor: P</a:t>
+            </a:r>
+            <a:r>
+              <a:rPr sz="2175" b="0" baseline="-25000">
+                <a:solidFill>
+                  <a:srgbClr val="111111"/>
+                </a:solidFill>
+                <a:latin typeface="Calibri"/>
+                <a:ea typeface="Calibri"/>
+                <a:cs typeface="Calibri"/>
+              </a:rPr>
+              <a:t>axel</a:t>
+            </a:r>
+            <a:r>
+              <a:rPr sz="2175" b="0">
+                <a:solidFill>
+                  <a:srgbClr val="111111"/>
+                </a:solidFill>
+                <a:latin typeface="Calibri"/>
+                <a:ea typeface="Calibri"/>
+                <a:cs typeface="Calibri"/>
+              </a:rPr>
+              <a:t> = 2,4 kW, η = 0,80, PF = 0,75 och U</a:t>
             </a:r>
             <a:r>
               <a:rPr sz="2175" b="0" baseline="-25000">
@@ -10447,7 +10601,7 @@
                 <a:ea typeface="Calibri"/>
                 <a:cs typeface="Calibri"/>
               </a:rPr>
-              <a:t>Pᵢₙ = Paxel/η     I</a:t>
+              <a:t>P</a:t>
             </a:r>
             <a:r>
               <a:rPr sz="2325" b="1" baseline="-25000">
@@ -10458,6 +10612,50 @@
                 <a:ea typeface="Calibri"/>
                 <a:cs typeface="Calibri"/>
               </a:rPr>
+              <a:t>in</a:t>
+            </a:r>
+            <a:r>
+              <a:rPr sz="2325" b="1">
+                <a:solidFill>
+                  <a:srgbClr val="064F91"/>
+                </a:solidFill>
+                <a:latin typeface="Calibri"/>
+                <a:ea typeface="Calibri"/>
+                <a:cs typeface="Calibri"/>
+              </a:rPr>
+              <a:t> = P</a:t>
+            </a:r>
+            <a:r>
+              <a:rPr sz="2325" b="1" baseline="-25000">
+                <a:solidFill>
+                  <a:srgbClr val="064F91"/>
+                </a:solidFill>
+                <a:latin typeface="Calibri"/>
+                <a:ea typeface="Calibri"/>
+                <a:cs typeface="Calibri"/>
+              </a:rPr>
+              <a:t>axel</a:t>
+            </a:r>
+            <a:r>
+              <a:rPr sz="2325" b="1">
+                <a:solidFill>
+                  <a:srgbClr val="064F91"/>
+                </a:solidFill>
+                <a:latin typeface="Calibri"/>
+                <a:ea typeface="Calibri"/>
+                <a:cs typeface="Calibri"/>
+              </a:rPr>
+              <a:t>/η     I</a:t>
+            </a:r>
+            <a:r>
+              <a:rPr sz="2325" b="1" baseline="-25000">
+                <a:solidFill>
+                  <a:srgbClr val="064F91"/>
+                </a:solidFill>
+                <a:latin typeface="Calibri"/>
+                <a:ea typeface="Calibri"/>
+                <a:cs typeface="Calibri"/>
+              </a:rPr>
               <a:t>L</a:t>
             </a:r>
             <a:r>
@@ -10469,7 +10667,29 @@
                 <a:ea typeface="Calibri"/>
                 <a:cs typeface="Calibri"/>
               </a:rPr>
-              <a:t> = Pᵢₙ/(√3 U</a:t>
+              <a:t> = P</a:t>
+            </a:r>
+            <a:r>
+              <a:rPr sz="2325" b="1" baseline="-25000">
+                <a:solidFill>
+                  <a:srgbClr val="064F91"/>
+                </a:solidFill>
+                <a:latin typeface="Calibri"/>
+                <a:ea typeface="Calibri"/>
+                <a:cs typeface="Calibri"/>
+              </a:rPr>
+              <a:t>in</a:t>
+            </a:r>
+            <a:r>
+              <a:rPr sz="2325" b="1">
+                <a:solidFill>
+                  <a:srgbClr val="064F91"/>
+                </a:solidFill>
+                <a:latin typeface="Calibri"/>
+                <a:ea typeface="Calibri"/>
+                <a:cs typeface="Calibri"/>
+              </a:rPr>
+              <a:t>/(√3 U</a:t>
             </a:r>
             <a:r>
               <a:rPr sz="2325" b="1" baseline="-25000">
@@ -10548,7 +10768,29 @@
                 <a:ea typeface="Calibri"/>
                 <a:cs typeface="Calibri"/>
               </a:rPr>
-              <a:t>1. Pᵢₙ = 2,4/0,80 = 3,0 kW = 3 000 W.</a:t>
+              <a:t>1. P</a:t>
+            </a:r>
+            <a:r>
+              <a:rPr sz="2063" b="0" baseline="-25000">
+                <a:solidFill>
+                  <a:srgbClr val="111111"/>
+                </a:solidFill>
+                <a:latin typeface="Calibri"/>
+                <a:ea typeface="Calibri"/>
+                <a:cs typeface="Calibri"/>
+              </a:rPr>
+              <a:t>in</a:t>
+            </a:r>
+            <a:r>
+              <a:rPr sz="2063" b="0">
+                <a:solidFill>
+                  <a:srgbClr val="111111"/>
+                </a:solidFill>
+                <a:latin typeface="Calibri"/>
+                <a:ea typeface="Calibri"/>
+                <a:cs typeface="Calibri"/>
+              </a:rPr>
+              <a:t> = 2,4/0,80 = 3,0 kW = 3 000 W.</a:t>
             </a:r>
           </a:p>
           <a:p xmlns:a="http://schemas.openxmlformats.org/drawingml/2006/main">
@@ -12485,7 +12727,51 @@
                 <a:ea typeface="Calibri"/>
                 <a:cs typeface="Calibri"/>
               </a:rPr>
-              <a:t>Pᵢₙ = Paxel/η</a:t>
+              <a:t>P</a:t>
+            </a:r>
+            <a:r>
+              <a:rPr sz="2400" b="1" baseline="-25000">
+                <a:solidFill>
+                  <a:srgbClr val="064F91"/>
+                </a:solidFill>
+                <a:latin typeface="Calibri"/>
+                <a:ea typeface="Calibri"/>
+                <a:cs typeface="Calibri"/>
+              </a:rPr>
+              <a:t>in</a:t>
+            </a:r>
+            <a:r>
+              <a:rPr sz="2400" b="1">
+                <a:solidFill>
+                  <a:srgbClr val="064F91"/>
+                </a:solidFill>
+                <a:latin typeface="Calibri"/>
+                <a:ea typeface="Calibri"/>
+                <a:cs typeface="Calibri"/>
+              </a:rPr>
+              <a:t> = P</a:t>
+            </a:r>
+            <a:r>
+              <a:rPr sz="2400" b="1" baseline="-25000">
+                <a:solidFill>
+                  <a:srgbClr val="064F91"/>
+                </a:solidFill>
+                <a:latin typeface="Calibri"/>
+                <a:ea typeface="Calibri"/>
+                <a:cs typeface="Calibri"/>
+              </a:rPr>
+              <a:t>axel</a:t>
+            </a:r>
+            <a:r>
+              <a:rPr sz="2400" b="1">
+                <a:solidFill>
+                  <a:srgbClr val="064F91"/>
+                </a:solidFill>
+                <a:latin typeface="Calibri"/>
+                <a:ea typeface="Calibri"/>
+                <a:cs typeface="Calibri"/>
+              </a:rPr>
+              <a:t>/η</a:t>
             </a:r>
           </a:p>
           <a:p xmlns:a="http://schemas.openxmlformats.org/drawingml/2006/main">
@@ -12530,7 +12816,29 @@
                 <a:ea typeface="Calibri"/>
                 <a:cs typeface="Calibri"/>
               </a:rPr>
-              <a:t> = Pᵢₙ/(√3 · U</a:t>
+              <a:t> = P</a:t>
+            </a:r>
+            <a:r>
+              <a:rPr sz="2400" b="1" baseline="-25000">
+                <a:solidFill>
+                  <a:srgbClr val="064F91"/>
+                </a:solidFill>
+                <a:latin typeface="Calibri"/>
+                <a:ea typeface="Calibri"/>
+                <a:cs typeface="Calibri"/>
+              </a:rPr>
+              <a:t>in</a:t>
+            </a:r>
+            <a:r>
+              <a:rPr sz="2400" b="1">
+                <a:solidFill>
+                  <a:srgbClr val="064F91"/>
+                </a:solidFill>
+                <a:latin typeface="Calibri"/>
+                <a:ea typeface="Calibri"/>
+                <a:cs typeface="Calibri"/>
+              </a:rPr>
+              <a:t>/(√3 · U</a:t>
             </a:r>
             <a:r>
               <a:rPr sz="2400" b="1" baseline="-25000">
@@ -12609,7 +12917,29 @@
                 <a:ea typeface="Calibri"/>
                 <a:cs typeface="Calibri"/>
               </a:rPr>
-              <a:t>Paxel är effekten på axeln och P</a:t>
+              <a:t>P</a:t>
+            </a:r>
+            <a:r>
+              <a:rPr sz="2100" b="0" baseline="-25000">
+                <a:solidFill>
+                  <a:srgbClr val="111111"/>
+                </a:solidFill>
+                <a:latin typeface="Calibri"/>
+                <a:ea typeface="Calibri"/>
+                <a:cs typeface="Calibri"/>
+              </a:rPr>
+              <a:t>axel</a:t>
+            </a:r>
+            <a:r>
+              <a:rPr sz="2100" b="0">
+                <a:solidFill>
+                  <a:srgbClr val="111111"/>
+                </a:solidFill>
+                <a:latin typeface="Calibri"/>
+                <a:ea typeface="Calibri"/>
+                <a:cs typeface="Calibri"/>
+              </a:rPr>
+              <a:t> är effekten på axeln och P</a:t>
             </a:r>
             <a:r>
               <a:rPr sz="2100" b="0" baseline="-25000">
@@ -12688,7 +13018,29 @@
                 <a:ea typeface="Calibri"/>
                 <a:cs typeface="Calibri"/>
               </a:rPr>
-              <a:t>Förutsättningar: Paxel = 5,5 kW, η = 0,88, PF = 0,80 och U</a:t>
+              <a:t>Förutsättningar: P</a:t>
+            </a:r>
+            <a:r>
+              <a:rPr sz="2025" b="0" baseline="-25000">
+                <a:solidFill>
+                  <a:srgbClr val="111111"/>
+                </a:solidFill>
+                <a:latin typeface="Calibri"/>
+                <a:ea typeface="Calibri"/>
+                <a:cs typeface="Calibri"/>
+              </a:rPr>
+              <a:t>axel</a:t>
+            </a:r>
+            <a:r>
+              <a:rPr sz="2025" b="0">
+                <a:solidFill>
+                  <a:srgbClr val="111111"/>
+                </a:solidFill>
+                <a:latin typeface="Calibri"/>
+                <a:ea typeface="Calibri"/>
+                <a:cs typeface="Calibri"/>
+              </a:rPr>
+              <a:t> = 5,5 kW, η = 0,88, PF = 0,80 och U</a:t>
             </a:r>
             <a:r>
               <a:rPr sz="2025" b="0" baseline="-25000">
@@ -13580,7 +13932,29 @@
                 <a:ea typeface="Calibri"/>
                 <a:cs typeface="Calibri"/>
               </a:rPr>
-              <a:t>En motor ger Paxel = 5,5 kW med η = 0,88 och PF = 0,80 vid U</a:t>
+              <a:t>En motor ger P</a:t>
+            </a:r>
+            <a:r>
+              <a:rPr sz="2400" b="0" baseline="-25000">
+                <a:solidFill>
+                  <a:srgbClr val="111111"/>
+                </a:solidFill>
+                <a:latin typeface="Calibri"/>
+                <a:ea typeface="Calibri"/>
+                <a:cs typeface="Calibri"/>
+              </a:rPr>
+              <a:t>axel</a:t>
+            </a:r>
+            <a:r>
+              <a:rPr sz="2400" b="0">
+                <a:solidFill>
+                  <a:srgbClr val="111111"/>
+                </a:solidFill>
+                <a:latin typeface="Calibri"/>
+                <a:ea typeface="Calibri"/>
+                <a:cs typeface="Calibri"/>
+              </a:rPr>
+              <a:t> = 5,5 kW med η = 0,88 och PF = 0,80 vid U</a:t>
             </a:r>
             <a:r>
               <a:rPr sz="2400" b="0" baseline="-25000">
@@ -13732,7 +14106,7 @@
           <p:nvPr/>
         </p:nvPicPr>
         <p:blipFill>
-          <a:blip r:embed="rId3"/>
+          <a:blip r:embed="rId4"/>
           <a:stretch>
             <a:fillRect/>
           </a:stretch>
@@ -14694,7 +15068,29 @@
                 <a:ea typeface="Calibri"/>
                 <a:cs typeface="Calibri"/>
               </a:rPr>
-              <a:t>Ptotal = P₁ + P₂ + P₃</a:t>
+              <a:t>P</a:t>
+            </a:r>
+            <a:r>
+              <a:rPr sz="2400" b="1" baseline="-25000">
+                <a:solidFill>
+                  <a:srgbClr val="064F91"/>
+                </a:solidFill>
+                <a:latin typeface="Calibri"/>
+                <a:ea typeface="Calibri"/>
+                <a:cs typeface="Calibri"/>
+              </a:rPr>
+              <a:t>total</a:t>
+            </a:r>
+            <a:r>
+              <a:rPr sz="2400" b="1">
+                <a:solidFill>
+                  <a:srgbClr val="064F91"/>
+                </a:solidFill>
+                <a:latin typeface="Calibri"/>
+                <a:ea typeface="Calibri"/>
+                <a:cs typeface="Calibri"/>
+              </a:rPr>
+              <a:t> = P₁ + P₂ + P₃</a:t>
             </a:r>
           </a:p>
         </p:txBody>
@@ -15294,7 +15690,7 @@
           <p:nvPr/>
         </p:nvPicPr>
         <p:blipFill>
-          <a:blip r:embed="rId3"/>
+          <a:blip r:embed="rId4"/>
           <a:stretch>
             <a:fillRect/>
           </a:stretch>

</xml_diff>

<commit_message>
Sjöskolan vecka 41–45: P_{förlust} och U_{ut} med index
Co-Authored-By: Claude Opus 5.5 <noreply@anthropic.com>
Claude-Session: https://claude.ai/code/session_011V9KjBb53XrDm23Dw58SH3
</commit_message>
<xml_diff>
--- a/sjoskolan/vecka-41/aktuell/v41_02_Y_och_trefaseffekt_elev.pptx
+++ b/sjoskolan/vecka-41/aktuell/v41_02_Y_och_trefaseffekt_elev.pptx
@@ -10858,7 +10858,29 @@
                 <a:ea typeface="Calibri"/>
                 <a:cs typeface="Calibri"/>
               </a:rPr>
-              <a:t>3. Pförlust = 3,0 − 2,4 = 0,60 kW.</a:t>
+              <a:t>3. P</a:t>
+            </a:r>
+            <a:r>
+              <a:rPr sz="2063" b="0" baseline="-25000">
+                <a:solidFill>
+                  <a:srgbClr val="111111"/>
+                </a:solidFill>
+                <a:latin typeface="Calibri"/>
+                <a:ea typeface="Calibri"/>
+                <a:cs typeface="Calibri"/>
+              </a:rPr>
+              <a:t>förlust</a:t>
+            </a:r>
+            <a:r>
+              <a:rPr sz="2063" b="0">
+                <a:solidFill>
+                  <a:srgbClr val="111111"/>
+                </a:solidFill>
+                <a:latin typeface="Calibri"/>
+                <a:ea typeface="Calibri"/>
+                <a:cs typeface="Calibri"/>
+              </a:rPr>
+              <a:t> = 3,0 − 2,4 = 0,60 kW.</a:t>
             </a:r>
           </a:p>
         </p:txBody>

</xml_diff>

<commit_message>
Sjöskolan v41 Del 2: nytt E2 ombord, rätta teorihänvisningar, princip i övning 2.7, Δ-spänning och osymmetrisk effekt
Co-Authored-By: Claude Opus 5.5 <noreply@anthropic.com>
Claude-Session: https://claude.ai/code/session_011V9KjBb53XrDm23Dw58SH3
</commit_message>
<xml_diff>
--- a/sjoskolan/vecka-41/aktuell/v41_02_Y_och_trefaseffekt_elev.pptx
+++ b/sjoskolan/vecka-41/aktuell/v41_02_Y_och_trefaseffekt_elev.pptx
@@ -10522,7 +10522,7 @@
                 <a:ea typeface="Calibri"/>
                 <a:cs typeface="Calibri"/>
               </a:rPr>
-              <a:t> = 2,4 kW, η = 0,80, PF = 0,75 och U</a:t>
+              <a:t> = 3,0 kW, η = 0,80, PF = 0,75 och U</a:t>
             </a:r>
             <a:r>
               <a:rPr sz="2175" b="0" baseline="-25000">
@@ -10544,7 +10544,7 @@
                 <a:ea typeface="Calibri"/>
                 <a:cs typeface="Calibri"/>
               </a:rPr>
-              <a:t> = 400 V. Symmetrisk trefas.</a:t>
+              <a:t> = 440 V ombord. Symmetrisk trefas.</a:t>
             </a:r>
           </a:p>
         </p:txBody>
@@ -10790,7 +10790,7 @@
                 <a:ea typeface="Calibri"/>
                 <a:cs typeface="Calibri"/>
               </a:rPr>
-              <a:t> = 2,4/0,80 = 3,0 kW = 3 000 W.</a:t>
+              <a:t> = 3,0/0,80 = 3,75 kW = 3 750 W.</a:t>
             </a:r>
           </a:p>
           <a:p xmlns:a="http://schemas.openxmlformats.org/drawingml/2006/main">
@@ -10835,7 +10835,7 @@
                 <a:ea typeface="Calibri"/>
                 <a:cs typeface="Calibri"/>
               </a:rPr>
-              <a:t> = 3 000/(√3 · 400 · 0,75) ≈ 5,77 A.</a:t>
+              <a:t> = 3 750/(√3 · 440 · 0,75) ≈ 6,56 A.</a:t>
             </a:r>
           </a:p>
           <a:p xmlns:a="http://schemas.openxmlformats.org/drawingml/2006/main">
@@ -10880,7 +10880,7 @@
                 <a:ea typeface="Calibri"/>
                 <a:cs typeface="Calibri"/>
               </a:rPr>
-              <a:t> = 3,0 − 2,4 = 0,60 kW.</a:t>
+              <a:t> = 3,75 − 3,0 = 0,75 kW.</a:t>
             </a:r>
           </a:p>
         </p:txBody>
@@ -11979,7 +11979,7 @@
                 <a:ea typeface="Calibri"/>
                 <a:cs typeface="Calibri"/>
               </a:rPr>
-              <a:t>Jämför nätets U</a:t>
+              <a:t>Nätets U</a:t>
             </a:r>
             <a:r>
               <a:rPr sz="2400" b="1" baseline="-25000">
@@ -12001,7 +12001,7 @@
                 <a:ea typeface="Calibri"/>
                 <a:cs typeface="Calibri"/>
               </a:rPr>
-              <a:t> med båda märkvärdena</a:t>
+              <a:t> = märkvärdet för driftkopplingen</a:t>
             </a:r>
           </a:p>
         </p:txBody>
@@ -16695,7 +16695,7 @@
                 <a:ea typeface="Calibri"/>
                 <a:cs typeface="Calibri"/>
               </a:rPr>
-              <a:t>I symmetrisk Δ är grenspänning och linjespänning lika.</a:t>
+              <a:t>I Δ är grenspänning och linjespänning alltid lika.</a:t>
             </a:r>
           </a:p>
         </p:txBody>
@@ -18535,6 +18535,30 @@
                 <a:cs typeface="Calibri"/>
               </a:rPr>
               <a:t>Vid sinusform gäller PF = cos φ.</a:t>
+            </a:r>
+          </a:p>
+          <a:p xmlns:a="http://schemas.openxmlformats.org/drawingml/2006/main">
+            <a:pPr algn="l">
+              <a:buNone/>
+              <a:defRPr sz="2400" b="0">
+                <a:solidFill>
+                  <a:srgbClr val="111111"/>
+                </a:solidFill>
+                <a:latin typeface="Calibri"/>
+                <a:ea typeface="Calibri"/>
+                <a:cs typeface="Calibri"/>
+              </a:defRPr>
+            </a:pPr>
+            <a:r>
+              <a:rPr sz="2400" b="0">
+                <a:solidFill>
+                  <a:srgbClr val="111111"/>
+                </a:solidFill>
+                <a:latin typeface="Calibri"/>
+                <a:ea typeface="Calibri"/>
+                <a:cs typeface="Calibri"/>
+              </a:rPr>
+              <a:t>Osymmetrisk last: summera fasernas aktiva effekter.</a:t>
             </a:r>
           </a:p>
         </p:txBody>

</xml_diff>

<commit_message>
Sjöskolan v41 Del 2: figurer som definierar U_gren, U_L och I_L1 = I_12 − I_31, lindningsspänning vid plinten
Co-Authored-By: Claude Opus 5.5 <noreply@anthropic.com>
Claude-Session: https://claude.ai/code/session_011V9KjBb53XrDm23Dw58SH3
</commit_message>
<xml_diff>
--- a/sjoskolan/vecka-41/aktuell/v41_02_Y_och_trefaseffekt_elev.pptx
+++ b/sjoskolan/vecka-41/aktuell/v41_02_Y_och_trefaseffekt_elev.pptx
@@ -9060,7 +9060,29 @@
                 <a:ea typeface="Calibri"/>
                 <a:cs typeface="Calibri"/>
               </a:rPr>
-              <a:t>Märkningen Δ/Y 230/400 V anger spänningen för varje koppling.</a:t>
+              <a:t>Märkningen Δ/Y 230/400 V anger nätets U</a:t>
+            </a:r>
+            <a:r>
+              <a:rPr sz="1800" b="0" baseline="-25000">
+                <a:solidFill>
+                  <a:srgbClr val="111111"/>
+                </a:solidFill>
+                <a:latin typeface="Calibri"/>
+                <a:ea typeface="Calibri"/>
+                <a:cs typeface="Calibri"/>
+              </a:rPr>
+              <a:t>L</a:t>
+            </a:r>
+            <a:r>
+              <a:rPr sz="1800" b="0">
+                <a:solidFill>
+                  <a:srgbClr val="111111"/>
+                </a:solidFill>
+                <a:latin typeface="Calibri"/>
+                <a:ea typeface="Calibri"/>
+                <a:cs typeface="Calibri"/>
+              </a:rPr>
+              <a:t> för varje koppling.</a:t>
             </a:r>
           </a:p>
           <a:p xmlns:a="http://schemas.openxmlformats.org/drawingml/2006/main">
@@ -9333,7 +9355,7 @@
       </p:sp>
       <p:pic xmlns:a="http://schemas.openxmlformats.org/drawingml/2006/main" xmlns:r="http://schemas.openxmlformats.org/officeDocument/2006/relationships">
         <p:nvPicPr>
-          <p:cNvPr id="9" name="Figur: Motorns kopplingsplint: Y med bygel över" descr="Motorns kopplingsplint: Y med bygel över W2, U2, V2 och Δ med byglar U1–W2, V1–U2, W1–V2"/>
+          <p:cNvPr id="9" name="Figur: Motorns kopplingsplint: Y med bygel över" descr="Motorns kopplingsplint: Y med bygel över W2, U2, V2 ger lindningsspänningen UL/√3; Δ med byglar U1–W2, V1–U2, W1–V2 ger lindningsspänningen UL"/>
           <p:cNvPicPr>
             <a:picLocks noChangeAspect="1"/>
           </p:cNvPicPr>
@@ -9348,7 +9370,7 @@
         <p:spPr>
           <a:xfrm>
             <a:off x="4892040" y="1645920"/>
-            <a:ext cx="3886200" cy="3071293"/>
+            <a:ext cx="3886200" cy="3252383"/>
           </a:xfrm>
           <a:prstGeom prst="rect">
             <a:avLst/>
@@ -17496,7 +17518,51 @@
                 <a:ea typeface="Calibri"/>
                 <a:cs typeface="Calibri"/>
               </a:rPr>
-              <a:t>I Y ligger varje lastgren mellan en fas och stjärnpunkten.</a:t>
+              <a:t>I Y ligger varje lastgren mellan en fas och stjärnpunkten: U</a:t>
+            </a:r>
+            <a:r>
+              <a:rPr sz="2100" b="0" baseline="-25000">
+                <a:solidFill>
+                  <a:srgbClr val="111111"/>
+                </a:solidFill>
+                <a:latin typeface="Calibri"/>
+                <a:ea typeface="Calibri"/>
+                <a:cs typeface="Calibri"/>
+              </a:rPr>
+              <a:t>gren</a:t>
+            </a:r>
+            <a:r>
+              <a:rPr sz="2100" b="0">
+                <a:solidFill>
+                  <a:srgbClr val="111111"/>
+                </a:solidFill>
+                <a:latin typeface="Calibri"/>
+                <a:ea typeface="Calibri"/>
+                <a:cs typeface="Calibri"/>
+              </a:rPr>
+              <a:t> = U</a:t>
+            </a:r>
+            <a:r>
+              <a:rPr sz="2100" b="0" baseline="-25000">
+                <a:solidFill>
+                  <a:srgbClr val="111111"/>
+                </a:solidFill>
+                <a:latin typeface="Calibri"/>
+                <a:ea typeface="Calibri"/>
+                <a:cs typeface="Calibri"/>
+              </a:rPr>
+              <a:t>F</a:t>
+            </a:r>
+            <a:r>
+              <a:rPr sz="2100" b="0">
+                <a:solidFill>
+                  <a:srgbClr val="111111"/>
+                </a:solidFill>
+                <a:latin typeface="Calibri"/>
+                <a:ea typeface="Calibri"/>
+                <a:cs typeface="Calibri"/>
+              </a:rPr>
+              <a:t>.</a:t>
             </a:r>
           </a:p>
           <a:p xmlns:a="http://schemas.openxmlformats.org/drawingml/2006/main">
@@ -17520,7 +17586,51 @@
                 <a:ea typeface="Calibri"/>
                 <a:cs typeface="Calibri"/>
               </a:rPr>
-              <a:t>I Δ ligger varje lastgren mellan två faser.</a:t>
+              <a:t>I Δ ligger varje lastgren mellan två faser: U</a:t>
+            </a:r>
+            <a:r>
+              <a:rPr sz="2100" b="0" baseline="-25000">
+                <a:solidFill>
+                  <a:srgbClr val="111111"/>
+                </a:solidFill>
+                <a:latin typeface="Calibri"/>
+                <a:ea typeface="Calibri"/>
+                <a:cs typeface="Calibri"/>
+              </a:rPr>
+              <a:t>gren</a:t>
+            </a:r>
+            <a:r>
+              <a:rPr sz="2100" b="0">
+                <a:solidFill>
+                  <a:srgbClr val="111111"/>
+                </a:solidFill>
+                <a:latin typeface="Calibri"/>
+                <a:ea typeface="Calibri"/>
+                <a:cs typeface="Calibri"/>
+              </a:rPr>
+              <a:t> = U</a:t>
+            </a:r>
+            <a:r>
+              <a:rPr sz="2100" b="0" baseline="-25000">
+                <a:solidFill>
+                  <a:srgbClr val="111111"/>
+                </a:solidFill>
+                <a:latin typeface="Calibri"/>
+                <a:ea typeface="Calibri"/>
+                <a:cs typeface="Calibri"/>
+              </a:rPr>
+              <a:t>L</a:t>
+            </a:r>
+            <a:r>
+              <a:rPr sz="2100" b="0">
+                <a:solidFill>
+                  <a:srgbClr val="111111"/>
+                </a:solidFill>
+                <a:latin typeface="Calibri"/>
+                <a:ea typeface="Calibri"/>
+                <a:cs typeface="Calibri"/>
+              </a:rPr>
+              <a:t>.</a:t>
             </a:r>
           </a:p>
         </p:txBody>
@@ -17802,22 +17912,22 @@
       </p:sp>
       <p:pic xmlns:a="http://schemas.openxmlformats.org/drawingml/2006/main" xmlns:r="http://schemas.openxmlformats.org/officeDocument/2006/relationships">
         <p:nvPicPr>
-          <p:cNvPr id="31" name="schema-y-delta" descr="Y: tre grenar mellan fas och stjärnpunkt. Δ: tre grenar mellan två faser."/>
+          <p:cNvPr id="31" name="schema-y-delta" descr="Y: varje gren ligger mellan en fas och stjärnpunkten, Ugren = UL/√3. Δ: varje gren ligger mellan två faser, Ugren = UL."/>
           <p:cNvPicPr>
             <a:picLocks noChangeAspect="1"/>
           </p:cNvPicPr>
           <p:nvPr/>
         </p:nvPicPr>
         <p:blipFill>
-          <a:blip r:embed="rId3"/>
+          <a:blip r:embed="rId5"/>
           <a:stretch>
             <a:fillRect/>
           </a:stretch>
         </p:blipFill>
         <p:spPr>
           <a:xfrm>
-            <a:off x="1542647" y="2395728"/>
-            <a:ext cx="6058706" cy="2340864"/>
+            <a:off x="2059853" y="2395728"/>
+            <a:ext cx="5024293" cy="2340864"/>
           </a:xfrm>
           <a:prstGeom prst="rect">
             <a:avLst/>
@@ -17981,7 +18091,51 @@
                 <a:ea typeface="Calibri"/>
                 <a:cs typeface="Calibri"/>
               </a:rPr>
-              <a:t>I Y passerar linjeströmmen genom en lastgren.</a:t>
+              <a:t>I Y går linjeströmmen rakt genom en gren: I</a:t>
+            </a:r>
+            <a:r>
+              <a:rPr sz="1900" b="0" baseline="-25000">
+                <a:solidFill>
+                  <a:srgbClr val="111111"/>
+                </a:solidFill>
+                <a:latin typeface="Calibri"/>
+                <a:ea typeface="Calibri"/>
+                <a:cs typeface="Calibri"/>
+              </a:rPr>
+              <a:t>L</a:t>
+            </a:r>
+            <a:r>
+              <a:rPr sz="1900" b="0">
+                <a:solidFill>
+                  <a:srgbClr val="111111"/>
+                </a:solidFill>
+                <a:latin typeface="Calibri"/>
+                <a:ea typeface="Calibri"/>
+                <a:cs typeface="Calibri"/>
+              </a:rPr>
+              <a:t> = I</a:t>
+            </a:r>
+            <a:r>
+              <a:rPr sz="1900" b="0" baseline="-25000">
+                <a:solidFill>
+                  <a:srgbClr val="111111"/>
+                </a:solidFill>
+                <a:latin typeface="Calibri"/>
+                <a:ea typeface="Calibri"/>
+                <a:cs typeface="Calibri"/>
+              </a:rPr>
+              <a:t>gren</a:t>
+            </a:r>
+            <a:r>
+              <a:rPr sz="1900" b="0">
+                <a:solidFill>
+                  <a:srgbClr val="111111"/>
+                </a:solidFill>
+                <a:latin typeface="Calibri"/>
+                <a:ea typeface="Calibri"/>
+                <a:cs typeface="Calibri"/>
+              </a:rPr>
+              <a:t>.</a:t>
             </a:r>
           </a:p>
           <a:p xmlns:a="http://schemas.openxmlformats.org/drawingml/2006/main">
@@ -18005,7 +18159,73 @@
                 <a:ea typeface="Calibri"/>
                 <a:cs typeface="Calibri"/>
               </a:rPr>
-              <a:t>I symmetrisk Δ är linjeströmmen en skillnad av grenvisare.</a:t>
+              <a:t>I Δ är linjeströmmen en vektoriell skillnad: I</a:t>
+            </a:r>
+            <a:r>
+              <a:rPr sz="1900" b="0" baseline="-25000">
+                <a:solidFill>
+                  <a:srgbClr val="111111"/>
+                </a:solidFill>
+                <a:latin typeface="Calibri"/>
+                <a:ea typeface="Calibri"/>
+                <a:cs typeface="Calibri"/>
+              </a:rPr>
+              <a:t>L1</a:t>
+            </a:r>
+            <a:r>
+              <a:rPr sz="1900" b="0">
+                <a:solidFill>
+                  <a:srgbClr val="111111"/>
+                </a:solidFill>
+                <a:latin typeface="Calibri"/>
+                <a:ea typeface="Calibri"/>
+                <a:cs typeface="Calibri"/>
+              </a:rPr>
+              <a:t> = I</a:t>
+            </a:r>
+            <a:r>
+              <a:rPr sz="1900" b="0" baseline="-25000">
+                <a:solidFill>
+                  <a:srgbClr val="111111"/>
+                </a:solidFill>
+                <a:latin typeface="Calibri"/>
+                <a:ea typeface="Calibri"/>
+                <a:cs typeface="Calibri"/>
+              </a:rPr>
+              <a:t>12</a:t>
+            </a:r>
+            <a:r>
+              <a:rPr sz="1900" b="0">
+                <a:solidFill>
+                  <a:srgbClr val="111111"/>
+                </a:solidFill>
+                <a:latin typeface="Calibri"/>
+                <a:ea typeface="Calibri"/>
+                <a:cs typeface="Calibri"/>
+              </a:rPr>
+              <a:t> − I</a:t>
+            </a:r>
+            <a:r>
+              <a:rPr sz="1900" b="0" baseline="-25000">
+                <a:solidFill>
+                  <a:srgbClr val="111111"/>
+                </a:solidFill>
+                <a:latin typeface="Calibri"/>
+                <a:ea typeface="Calibri"/>
+                <a:cs typeface="Calibri"/>
+              </a:rPr>
+              <a:t>31</a:t>
+            </a:r>
+            <a:r>
+              <a:rPr sz="1900" b="0">
+                <a:solidFill>
+                  <a:srgbClr val="111111"/>
+                </a:solidFill>
+                <a:latin typeface="Calibri"/>
+                <a:ea typeface="Calibri"/>
+                <a:cs typeface="Calibri"/>
+              </a:rPr>
+              <a:t>.</a:t>
             </a:r>
           </a:p>
         </p:txBody>
@@ -18331,7 +18551,7 @@
       </p:sp>
       <p:pic xmlns:a="http://schemas.openxmlformats.org/drawingml/2006/main" xmlns:r="http://schemas.openxmlformats.org/officeDocument/2006/relationships">
         <p:nvPicPr>
-          <p:cNvPr id="9" name="Figur: Δ-last där linjeströmmen i L1 delar sig " descr="Δ-last där linjeströmmen i L1 delar sig i två grenströmmar"/>
+          <p:cNvPr id="9" name="Figur: Δ-last där linjeströmmen i L1 delar sig " descr="Δ-last: linjeströmmen IL1 delar sig i grenströmmarna I12 och I31. Visarbilden visar IL1 = I12 − I31 som vektoriell skillnad, √3 gånger grenströmmen"/>
           <p:cNvPicPr>
             <a:picLocks noChangeAspect="1"/>
           </p:cNvPicPr>
@@ -18345,8 +18565,8 @@
         </p:blipFill>
         <p:spPr>
           <a:xfrm>
-            <a:off x="4892040" y="1645920"/>
-            <a:ext cx="3886200" cy="3252383"/>
+            <a:off x="4578240" y="1645920"/>
+            <a:ext cx="4200000" cy="2907941"/>
           </a:xfrm>
           <a:prstGeom prst="rect">
             <a:avLst/>

</xml_diff>

<commit_message>
Sjöskolan v41: figurer för trefaseffekt och transformator i del 2, Motorlabbet i 3D för labbet på distans
Co-Authored-By: Claude Opus 5.5 <noreply@anthropic.com>
Claude-Session: https://claude.ai/code/session_011V9KjBb53XrDm23Dw58SH3
</commit_message>
<xml_diff>
--- a/sjoskolan/vecka-41/aktuell/v41_02_Y_och_trefaseffekt_elev.pptx
+++ b/sjoskolan/vecka-41/aktuell/v41_02_Y_och_trefaseffekt_elev.pptx
@@ -10016,7 +10016,7 @@
         <p:spPr>
           <a:xfrm xmlns:a="http://schemas.openxmlformats.org/drawingml/2006/main">
             <a:off x="762000" y="1619250"/>
-            <a:ext cx="7620000" cy="1466850"/>
+            <a:ext cx="3977639" cy="1466850"/>
           </a:xfrm>
           <a:prstGeom xmlns:a="http://schemas.openxmlformats.org/drawingml/2006/main" prst="rect">
             <a:avLst/>
@@ -10044,7 +10044,7 @@
               </a:defRPr>
             </a:pPr>
             <a:r>
-              <a:rPr sz="2400" b="0">
+              <a:rPr sz="1900" b="0">
                 <a:solidFill>
                   <a:srgbClr val="111111"/>
                 </a:solidFill>
@@ -10068,7 +10068,7 @@
               </a:defRPr>
             </a:pPr>
             <a:r>
-              <a:rPr sz="2400" b="0">
+              <a:rPr sz="1900" b="0">
                 <a:solidFill>
                   <a:srgbClr val="111111"/>
                 </a:solidFill>
@@ -10098,7 +10098,7 @@
         <p:spPr>
           <a:xfrm xmlns:a="http://schemas.openxmlformats.org/drawingml/2006/main">
             <a:off x="762000" y="3200400"/>
-            <a:ext cx="7620000" cy="838200"/>
+            <a:ext cx="3977639" cy="838200"/>
           </a:xfrm>
           <a:prstGeom xmlns:a="http://schemas.openxmlformats.org/drawingml/2006/main" prst="rect">
             <a:avLst/>
@@ -10126,7 +10126,7 @@
               </a:defRPr>
             </a:pPr>
             <a:r>
-              <a:rPr sz="2925" b="1">
+              <a:rPr sz="2650" b="1">
                 <a:solidFill>
                   <a:srgbClr val="064F91"/>
                 </a:solidFill>
@@ -10137,7 +10137,7 @@
               <a:t>U</a:t>
             </a:r>
             <a:r>
-              <a:rPr sz="2925" b="1" baseline="-25000">
+              <a:rPr sz="2650" b="1" baseline="-25000">
                 <a:solidFill>
                   <a:srgbClr val="064F91"/>
                 </a:solidFill>
@@ -10148,7 +10148,7 @@
               <a:t>1,gren</a:t>
             </a:r>
             <a:r>
-              <a:rPr sz="2925" b="1">
+              <a:rPr sz="2650" b="1">
                 <a:solidFill>
                   <a:srgbClr val="064F91"/>
                 </a:solidFill>
@@ -10159,7 +10159,7 @@
               <a:t>/U</a:t>
             </a:r>
             <a:r>
-              <a:rPr sz="2925" b="1" baseline="-25000">
+              <a:rPr sz="2650" b="1" baseline="-25000">
                 <a:solidFill>
                   <a:srgbClr val="064F91"/>
                 </a:solidFill>
@@ -10170,7 +10170,7 @@
               <a:t>2,gren</a:t>
             </a:r>
             <a:r>
-              <a:rPr sz="2925" b="1">
+              <a:rPr sz="2650" b="1">
                 <a:solidFill>
                   <a:srgbClr val="064F91"/>
                 </a:solidFill>
@@ -10178,7 +10178,7 @@
                 <a:ea typeface="Calibri"/>
                 <a:cs typeface="Calibri"/>
               </a:rPr>
-              <a:t> = N₁/N₂</a:t>
+              <a:t> = N₁/N₂</a:t>
             </a:r>
           </a:p>
         </p:txBody>
@@ -10200,7 +10200,7 @@
         <p:spPr>
           <a:xfrm xmlns:a="http://schemas.openxmlformats.org/drawingml/2006/main">
             <a:off x="762000" y="4429125"/>
-            <a:ext cx="7620000" cy="1352550"/>
+            <a:ext cx="3977639" cy="1352550"/>
           </a:xfrm>
           <a:prstGeom xmlns:a="http://schemas.openxmlformats.org/drawingml/2006/main" prst="rect">
             <a:avLst/>
@@ -10228,18 +10228,18 @@
               </a:defRPr>
             </a:pPr>
             <a:r>
-              <a:rPr sz="2250" b="0">
-                <a:solidFill>
-                  <a:srgbClr val="111111"/>
-                </a:solidFill>
-                <a:latin typeface="Calibri"/>
-                <a:ea typeface="Calibri"/>
-                <a:cs typeface="Calibri"/>
-              </a:rPr>
-              <a:t>I uppgifterna med angivna linjespänningar används S = √3 U</a:t>
-            </a:r>
-            <a:r>
-              <a:rPr sz="2250" b="0" baseline="-25000">
+              <a:rPr sz="1800" b="0">
+                <a:solidFill>
+                  <a:srgbClr val="111111"/>
+                </a:solidFill>
+                <a:latin typeface="Calibri"/>
+                <a:ea typeface="Calibri"/>
+                <a:cs typeface="Calibri"/>
+              </a:rPr>
+              <a:t>I uppgifterna med angivna linjespänningar används S = √3 U</a:t>
+            </a:r>
+            <a:r>
+              <a:rPr sz="1800" b="0" baseline="-25000">
                 <a:solidFill>
                   <a:srgbClr val="111111"/>
                 </a:solidFill>
@@ -10250,7 +10250,7 @@
               <a:t>L</a:t>
             </a:r>
             <a:r>
-              <a:rPr sz="2250" b="0">
+              <a:rPr sz="1800" b="0">
                 <a:solidFill>
                   <a:srgbClr val="111111"/>
                 </a:solidFill>
@@ -10261,7 +10261,7 @@
               <a:t>I</a:t>
             </a:r>
             <a:r>
-              <a:rPr sz="2250" b="0" baseline="-25000">
+              <a:rPr sz="1800" b="0" baseline="-25000">
                 <a:solidFill>
                   <a:srgbClr val="111111"/>
                 </a:solidFill>
@@ -10272,7 +10272,7 @@
               <a:t>L</a:t>
             </a:r>
             <a:r>
-              <a:rPr sz="2250" b="0">
+              <a:rPr sz="1800" b="0">
                 <a:solidFill>
                   <a:srgbClr val="111111"/>
                 </a:solidFill>
@@ -10296,7 +10296,7 @@
               </a:defRPr>
             </a:pPr>
             <a:r>
-              <a:rPr sz="2250" b="0">
+              <a:rPr sz="1800" b="0">
                 <a:solidFill>
                   <a:srgbClr val="111111"/>
                 </a:solidFill>
@@ -10367,6 +10367,30 @@
           </a:p>
         </p:txBody>
       </p:sp>
+      <p:pic xmlns:a="http://schemas.openxmlformats.org/drawingml/2006/main" xmlns:r="http://schemas.openxmlformats.org/officeDocument/2006/relationships">
+        <p:nvPicPr>
+          <p:cNvPr id="9" name="Figur: Trefastransformator Dyn: primär Δ 6,6 kV" descr="Trefastransformator Dyn: primär Δ 6,6 kV med U1,gren = 6 600 V, sekundär Y 440 V med U2,gren ≈ 254 V; N1/N2 = U1,gren/U2,gren"/>
+          <p:cNvPicPr>
+            <a:picLocks noChangeAspect="1"/>
+          </p:cNvPicPr>
+          <p:nvPr/>
+        </p:nvPicPr>
+        <p:blipFill>
+          <a:blip r:embed="rId3"/>
+          <a:stretch>
+            <a:fillRect/>
+          </a:stretch>
+        </p:blipFill>
+        <p:spPr>
+          <a:xfrm>
+            <a:off x="4892040" y="1645920"/>
+            <a:ext cx="3886200" cy="2426442"/>
+          </a:xfrm>
+          <a:prstGeom prst="rect">
+            <a:avLst/>
+          </a:prstGeom>
+        </p:spPr>
+      </p:pic>
     </p:spTree>
     <p:extLst>
       <p:ext uri="{BB962C8B-B14F-4D97-AF65-F5344CB8AC3E}">
@@ -18694,7 +18718,7 @@
         <p:spPr>
           <a:xfrm xmlns:a="http://schemas.openxmlformats.org/drawingml/2006/main">
             <a:off x="762000" y="1619250"/>
-            <a:ext cx="7620000" cy="1466850"/>
+            <a:ext cx="3977639" cy="1466850"/>
           </a:xfrm>
           <a:prstGeom xmlns:a="http://schemas.openxmlformats.org/drawingml/2006/main" prst="rect">
             <a:avLst/>
@@ -18722,7 +18746,7 @@
               </a:defRPr>
             </a:pPr>
             <a:r>
-              <a:rPr sz="2400" b="0">
+              <a:rPr sz="1750" b="0">
                 <a:solidFill>
                   <a:srgbClr val="111111"/>
                 </a:solidFill>
@@ -18746,15 +18770,15 @@
               </a:defRPr>
             </a:pPr>
             <a:r>
-              <a:rPr sz="2400" b="0">
-                <a:solidFill>
-                  <a:srgbClr val="111111"/>
-                </a:solidFill>
-                <a:latin typeface="Calibri"/>
-                <a:ea typeface="Calibri"/>
-                <a:cs typeface="Calibri"/>
-              </a:rPr>
-              <a:t>Vid sinusform gäller PF = cos φ.</a:t>
+              <a:rPr sz="1750" b="0">
+                <a:solidFill>
+                  <a:srgbClr val="111111"/>
+                </a:solidFill>
+                <a:latin typeface="Calibri"/>
+                <a:ea typeface="Calibri"/>
+                <a:cs typeface="Calibri"/>
+              </a:rPr>
+              <a:t>Vid sinusform gäller PF = cos φ.</a:t>
             </a:r>
           </a:p>
           <a:p xmlns:a="http://schemas.openxmlformats.org/drawingml/2006/main">
@@ -18770,7 +18794,7 @@
               </a:defRPr>
             </a:pPr>
             <a:r>
-              <a:rPr sz="2400" b="0">
+              <a:rPr sz="1750" b="0">
                 <a:solidFill>
                   <a:srgbClr val="111111"/>
                 </a:solidFill>
@@ -18800,7 +18824,7 @@
         <p:spPr>
           <a:xfrm xmlns:a="http://schemas.openxmlformats.org/drawingml/2006/main">
             <a:off x="762000" y="3200400"/>
-            <a:ext cx="7620000" cy="838200"/>
+            <a:ext cx="3977639" cy="838200"/>
           </a:xfrm>
           <a:prstGeom xmlns:a="http://schemas.openxmlformats.org/drawingml/2006/main" prst="rect">
             <a:avLst/>
@@ -18828,7 +18852,7 @@
               </a:defRPr>
             </a:pPr>
             <a:r>
-              <a:rPr sz="2925" b="1">
+              <a:rPr sz="2650" b="1">
                 <a:solidFill>
                   <a:srgbClr val="064F91"/>
                 </a:solidFill>
@@ -18836,10 +18860,10 @@
                 <a:ea typeface="Calibri"/>
                 <a:cs typeface="Calibri"/>
               </a:rPr>
-              <a:t>S = √3 U</a:t>
-            </a:r>
-            <a:r>
-              <a:rPr sz="2925" b="1" baseline="-25000">
+              <a:t>S = √3 U</a:t>
+            </a:r>
+            <a:r>
+              <a:rPr sz="2650" b="1" baseline="-25000">
                 <a:solidFill>
                   <a:srgbClr val="064F91"/>
                 </a:solidFill>
@@ -18850,7 +18874,7 @@
               <a:t>L</a:t>
             </a:r>
             <a:r>
-              <a:rPr sz="2925" b="1">
+              <a:rPr sz="2650" b="1">
                 <a:solidFill>
                   <a:srgbClr val="064F91"/>
                 </a:solidFill>
@@ -18861,7 +18885,7 @@
               <a:t>I</a:t>
             </a:r>
             <a:r>
-              <a:rPr sz="2925" b="1" baseline="-25000">
+              <a:rPr sz="2650" b="1" baseline="-25000">
                 <a:solidFill>
                   <a:srgbClr val="064F91"/>
                 </a:solidFill>
@@ -18872,7 +18896,7 @@
               <a:t>L</a:t>
             </a:r>
             <a:r>
-              <a:rPr sz="2925" b="1">
+              <a:rPr sz="2650" b="1">
                 <a:solidFill>
                   <a:srgbClr val="064F91"/>
                 </a:solidFill>
@@ -18880,10 +18904,10 @@
                 <a:ea typeface="Calibri"/>
                 <a:cs typeface="Calibri"/>
               </a:rPr>
-              <a:t>     P = √3 U</a:t>
-            </a:r>
-            <a:r>
-              <a:rPr sz="2925" b="1" baseline="-25000">
+              <a:t>     P = √3 U</a:t>
+            </a:r>
+            <a:r>
+              <a:rPr sz="2650" b="1" baseline="-25000">
                 <a:solidFill>
                   <a:srgbClr val="064F91"/>
                 </a:solidFill>
@@ -18894,7 +18918,7 @@
               <a:t>L</a:t>
             </a:r>
             <a:r>
-              <a:rPr sz="2925" b="1">
+              <a:rPr sz="2650" b="1">
                 <a:solidFill>
                   <a:srgbClr val="064F91"/>
                 </a:solidFill>
@@ -18905,7 +18929,7 @@
               <a:t>I</a:t>
             </a:r>
             <a:r>
-              <a:rPr sz="2925" b="1" baseline="-25000">
+              <a:rPr sz="2650" b="1" baseline="-25000">
                 <a:solidFill>
                   <a:srgbClr val="064F91"/>
                 </a:solidFill>
@@ -18916,7 +18940,7 @@
               <a:t>L</a:t>
             </a:r>
             <a:r>
-              <a:rPr sz="2925" b="1">
+              <a:rPr sz="2650" b="1">
                 <a:solidFill>
                   <a:srgbClr val="064F91"/>
                 </a:solidFill>
@@ -18924,7 +18948,7 @@
                 <a:ea typeface="Calibri"/>
                 <a:cs typeface="Calibri"/>
               </a:rPr>
-              <a:t> cos φ</a:t>
+              <a:t> cos φ</a:t>
             </a:r>
           </a:p>
         </p:txBody>
@@ -18946,7 +18970,7 @@
         <p:spPr>
           <a:xfrm xmlns:a="http://schemas.openxmlformats.org/drawingml/2006/main">
             <a:off x="762000" y="4429125"/>
-            <a:ext cx="7620000" cy="1352550"/>
+            <a:ext cx="3977639" cy="1352550"/>
           </a:xfrm>
           <a:prstGeom xmlns:a="http://schemas.openxmlformats.org/drawingml/2006/main" prst="rect">
             <a:avLst/>
@@ -18974,15 +18998,15 @@
               </a:defRPr>
             </a:pPr>
             <a:r>
-              <a:rPr sz="2250" b="0">
-                <a:solidFill>
-                  <a:srgbClr val="111111"/>
-                </a:solidFill>
-                <a:latin typeface="Calibri"/>
-                <a:ea typeface="Calibri"/>
-                <a:cs typeface="Calibri"/>
-              </a:rPr>
-              <a:t>440 V, 20 A och cos φ = 0,85 ger</a:t>
+              <a:rPr sz="2100" b="0">
+                <a:solidFill>
+                  <a:srgbClr val="111111"/>
+                </a:solidFill>
+                <a:latin typeface="Calibri"/>
+                <a:ea typeface="Calibri"/>
+                <a:cs typeface="Calibri"/>
+              </a:rPr>
+              <a:t>440 V, 20 A och cos φ = 0,85 ger</a:t>
             </a:r>
           </a:p>
           <a:p xmlns:a="http://schemas.openxmlformats.org/drawingml/2006/main">
@@ -18998,15 +19022,15 @@
               </a:defRPr>
             </a:pPr>
             <a:r>
-              <a:rPr sz="2250" b="0">
-                <a:solidFill>
-                  <a:srgbClr val="111111"/>
-                </a:solidFill>
-                <a:latin typeface="Calibri"/>
-                <a:ea typeface="Calibri"/>
-                <a:cs typeface="Calibri"/>
-              </a:rPr>
-              <a:t>S ≈ 15,2 kVA och P ≈ 13,0 kW.</a:t>
+              <a:rPr sz="2100" b="0">
+                <a:solidFill>
+                  <a:srgbClr val="111111"/>
+                </a:solidFill>
+                <a:latin typeface="Calibri"/>
+                <a:ea typeface="Calibri"/>
+                <a:cs typeface="Calibri"/>
+              </a:rPr>
+              <a:t>S ≈ 15,2 kVA och P ≈ 13,0 kW.</a:t>
             </a:r>
           </a:p>
         </p:txBody>
@@ -19069,6 +19093,30 @@
           </a:p>
         </p:txBody>
       </p:sp>
+      <p:pic xmlns:a="http://schemas.openxmlformats.org/drawingml/2006/main" xmlns:r="http://schemas.openxmlformats.org/officeDocument/2006/relationships">
+        <p:nvPicPr>
+          <p:cNvPr id="9" name="Figur: Effekttriangel för 440 V, 20 A och cos φ" descr="Effekttriangel för 440 V, 20 A och cos φ = 0,85: P ≈ 13,0 kW, Q ≈ 8,0 kvar och S ≈ 15,2 kVA"/>
+          <p:cNvPicPr>
+            <a:picLocks noChangeAspect="1"/>
+          </p:cNvPicPr>
+          <p:nvPr/>
+        </p:nvPicPr>
+        <p:blipFill>
+          <a:blip r:embed="rId3"/>
+          <a:stretch>
+            <a:fillRect/>
+          </a:stretch>
+        </p:blipFill>
+        <p:spPr>
+          <a:xfrm>
+            <a:off x="4892040" y="1645920"/>
+            <a:ext cx="3886200" cy="2890202"/>
+          </a:xfrm>
+          <a:prstGeom prst="rect">
+            <a:avLst/>
+          </a:prstGeom>
+        </p:spPr>
+      </p:pic>
     </p:spTree>
     <p:extLst>
       <p:ext uri="{BB962C8B-B14F-4D97-AF65-F5344CB8AC3E}">

</xml_diff>